<commit_message>
Convite: logo atual do SENAI e verso da capa
- Substitui o selo de texto pelo logo atual do SENAI (plaqueta branca na capa)
- Segundo slide passa a ser o verso da capa, só com o logo centralizado
- Acentos em laranja SENAI (#E84910) para combinar com a marca
- Cinco opções de título nas anotações do slide 1

Co-Authored-By: Claude Opus 5.5 <noreply@anthropic.com>
Claude-Session: https://claude.ai/code/session_015fDDoufnzCV884FLxp7NTd
</commit_message>
<xml_diff>
--- a/convites/convite-seminario-almoxarifado-senai.pptx
+++ b/convites/convite-seminario-almoxarifado-senai.pptx
@@ -503,7 +503,8 @@
           <a:p>
             <a:r>
               <a:rPr lang="en-US" dirty="0"/>
-              <a:t>COMO PERSONALIZAR: clique no texto "Nome do Convidado" e digite o nome da pessoa (o tamanho da fonte se ajusta sozinho para nomes longos). Para fazer um convite por pessoa, clique com o botão direito na miniatura deste slide &gt; Duplicar slide, e troque apenas o nome. Se desejar, substitua o selo "SENAI" pelo logotipo oficial da sua unidade.</a:t>
+              <a:t>COMO PERSONALIZAR: clique no texto "Nome do Convidado" e digite o nome da pessoa (o tamanho da fonte se ajusta sozinho para nomes longos). Para fazer um convite por pessoa, clique com o botão direito na miniatura deste slide &gt; Duplicar slide, e troque apenas o nome. 
+OPÇÕES DE TÍTULO: (1) Por Trás de Cada Prateleira; (2) Cada Caixa Conta uma História; (3) O Coração da Indústria; (4) Muito Além do Estoque; (5) Mãos que Organizam, Indústria que Avança.</a:t>
             </a:r>
             <a:endParaRPr lang="en-US" dirty="0"/>
           </a:p>
@@ -591,7 +592,7 @@
           <a:p>
             <a:r>
               <a:rPr lang="en-US" dirty="0"/>
-              <a:t/>
+              <a:t>Verso do convite (parte de trás da capa), com o logo do SENAI centralizado.</a:t>
             </a:r>
             <a:endParaRPr lang="en-US" dirty="0"/>
           </a:p>
@@ -1035,7 +1036,7 @@
           </a:prstGeom>
           <a:ln w="22225">
             <a:solidFill>
-              <a:srgbClr val="E30613"/>
+              <a:srgbClr val="E84910"/>
             </a:solidFill>
             <a:prstDash val="solid"/>
           </a:ln>
@@ -1057,7 +1058,7 @@
           </a:prstGeom>
           <a:ln w="15875">
             <a:solidFill>
-              <a:srgbClr val="E30613"/>
+              <a:srgbClr val="E84910"/>
             </a:solidFill>
             <a:prstDash val="solid"/>
           </a:ln>
@@ -1079,7 +1080,7 @@
           </a:prstGeom>
           <a:ln w="12700">
             <a:solidFill>
-              <a:srgbClr val="E30613"/>
+              <a:srgbClr val="E84910"/>
             </a:solidFill>
             <a:prstDash val="solid"/>
           </a:ln>
@@ -1100,7 +1101,7 @@
             <a:avLst/>
           </a:prstGeom>
           <a:solidFill>
-            <a:srgbClr val="E30613"/>
+            <a:srgbClr val="E84910"/>
           </a:solidFill>
           <a:ln/>
         </p:spPr>
@@ -1121,7 +1122,7 @@
           </a:prstGeom>
           <a:ln w="22225">
             <a:solidFill>
-              <a:srgbClr val="E30613"/>
+              <a:srgbClr val="E84910"/>
             </a:solidFill>
             <a:prstDash val="solid"/>
           </a:ln>
@@ -1143,7 +1144,7 @@
           </a:prstGeom>
           <a:ln w="15875">
             <a:solidFill>
-              <a:srgbClr val="E30613"/>
+              <a:srgbClr val="E84910"/>
             </a:solidFill>
             <a:prstDash val="solid"/>
           </a:ln>
@@ -1165,7 +1166,7 @@
           </a:prstGeom>
           <a:ln w="12700">
             <a:solidFill>
-              <a:srgbClr val="E30613"/>
+              <a:srgbClr val="E84910"/>
             </a:solidFill>
             <a:prstDash val="solid"/>
           </a:ln>
@@ -1186,55 +1187,43 @@
             <a:avLst/>
           </a:prstGeom>
           <a:solidFill>
-            <a:srgbClr val="E30613"/>
+            <a:srgbClr val="E84910"/>
           </a:solidFill>
           <a:ln/>
         </p:spPr>
       </p:sp>
       <p:sp>
         <p:nvSpPr>
-          <p:cNvPr id="12" name="Text 10"/>
-          <p:cNvSpPr txBox="1"/>
-          <p:nvPr/>
-        </p:nvSpPr>
-        <p:spPr>
-          <a:xfrm>
-            <a:off x="5318608" y="109728"/>
-            <a:ext cx="1554480" cy="347472"/>
-          </a:xfrm>
-          <a:prstGeom prst="rect">
-            <a:avLst/>
-          </a:prstGeom>
-          <a:solidFill>
-            <a:srgbClr val="E30613"/>
+          <p:cNvPr id="12" name="Shape 10"/>
+          <p:cNvSpPr/>
+          <p:nvPr/>
+        </p:nvSpPr>
+        <p:spPr>
+          <a:xfrm>
+            <a:off x="5227168" y="45720"/>
+            <a:ext cx="1737360" cy="457200"/>
+          </a:xfrm>
+          <a:prstGeom prst="roundRect">
+            <a:avLst>
+              <a:gd name="adj" fmla="val 12000"/>
+            </a:avLst>
+          </a:prstGeom>
+          <a:solidFill>
+            <a:srgbClr val="FFFFFF"/>
           </a:solidFill>
           <a:ln/>
-        </p:spPr>
-        <p:txBody>
-          <a:bodyPr wrap="square" lIns="0" tIns="0" rIns="0" bIns="0" rtlCol="0" anchor="ctr"/>
-          <a:lstStyle/>
-          <a:p>
-            <a:pPr algn="ctr" indent="0" marL="0">
-              <a:buNone/>
-            </a:pPr>
-            <a:r>
-              <a:rPr lang="en-US" sz="1800" b="1" i="1" spc="300" kern="0" dirty="0">
-                <a:solidFill>
-                  <a:srgbClr val="FFFFFF"/>
-                </a:solidFill>
-                <a:latin typeface="Arial" pitchFamily="34" charset="0"/>
-                <a:ea typeface="Arial" pitchFamily="34" charset="-122"/>
-                <a:cs typeface="Arial" pitchFamily="34" charset="-120"/>
-              </a:rPr>
-              <a:t>SENAI</a:t>
-            </a:r>
-            <a:endParaRPr lang="en-US" sz="1800" dirty="0"/>
-          </a:p>
-        </p:txBody>
+          <a:effectLst>
+            <a:outerShdw sx="100000" sy="100000" kx="0" ky="0" algn="bl" rotWithShape="0" blurRad="76200" dist="25400" dir="5400000">
+              <a:srgbClr val="000000">
+                <a:alpha val="35000"/>
+              </a:srgbClr>
+            </a:outerShdw>
+          </a:effectLst>
+        </p:spPr>
       </p:sp>
       <p:pic>
         <p:nvPicPr>
-          <p:cNvPr id="13" name="Image 0" descr="Palete com caixas de papelão">    </p:cNvPr>
+          <p:cNvPr id="13" name="Image 0" descr="Logo SENAI">    </p:cNvPr>
           <p:cNvPicPr>
             <a:picLocks noChangeAspect="1"/>
           </p:cNvPicPr>
@@ -1248,8 +1237,8 @@
         </p:blipFill>
         <p:spPr>
           <a:xfrm>
-            <a:off x="45720" y="4691416"/>
-            <a:ext cx="2419894" cy="2166584"/>
+            <a:off x="5572950" y="137160"/>
+            <a:ext cx="1045795" cy="274320"/>
           </a:xfrm>
           <a:prstGeom prst="rect">
             <a:avLst/>
@@ -1258,7 +1247,7 @@
       </p:pic>
       <p:pic>
         <p:nvPicPr>
-          <p:cNvPr id="14" name="Image 1" descr="Porta-palete com caixas armazenadas">    </p:cNvPr>
+          <p:cNvPr id="14" name="Image 1" descr="Palete com caixas de papelão">    </p:cNvPr>
           <p:cNvPicPr>
             <a:picLocks noChangeAspect="1"/>
           </p:cNvPicPr>
@@ -1272,8 +1261,8 @@
         </p:blipFill>
         <p:spPr>
           <a:xfrm>
-            <a:off x="9709752" y="2447109"/>
-            <a:ext cx="2481943" cy="4410891"/>
+            <a:off x="45720" y="4691416"/>
+            <a:ext cx="2419894" cy="2166584"/>
           </a:xfrm>
           <a:prstGeom prst="rect">
             <a:avLst/>
@@ -1282,7 +1271,7 @@
       </p:pic>
       <p:pic>
         <p:nvPicPr>
-          <p:cNvPr id="15" name="Image 2" descr="Ícone de armazém">    </p:cNvPr>
+          <p:cNvPr id="15" name="Image 2" descr="Porta-palete com caixas armazenadas">    </p:cNvPr>
           <p:cNvPicPr>
             <a:picLocks noChangeAspect="1"/>
           </p:cNvPicPr>
@@ -1296,17 +1285,41 @@
         </p:blipFill>
         <p:spPr>
           <a:xfrm>
-            <a:off x="5455768" y="530352"/>
-            <a:ext cx="1280160" cy="1280160"/>
+            <a:off x="9709752" y="2447109"/>
+            <a:ext cx="2481943" cy="4410891"/>
           </a:xfrm>
           <a:prstGeom prst="rect">
             <a:avLst/>
           </a:prstGeom>
         </p:spPr>
       </p:pic>
-      <p:sp>
-        <p:nvSpPr>
-          <p:cNvPr id="16" name="Text 11"/>
+      <p:pic>
+        <p:nvPicPr>
+          <p:cNvPr id="16" name="Image 3" descr="Ícone de armazém">    </p:cNvPr>
+          <p:cNvPicPr>
+            <a:picLocks noChangeAspect="1"/>
+          </p:cNvPicPr>
+          <p:nvPr/>
+        </p:nvPicPr>
+        <p:blipFill>
+          <a:blip r:embed="rId5"/>
+          <a:stretch>
+            <a:fillRect/>
+          </a:stretch>
+        </p:blipFill>
+        <p:spPr>
+          <a:xfrm>
+            <a:off x="5483200" y="566928"/>
+            <a:ext cx="1225296" cy="1225296"/>
+          </a:xfrm>
+          <a:prstGeom prst="rect">
+            <a:avLst/>
+          </a:prstGeom>
+        </p:spPr>
+      </p:pic>
+      <p:sp>
+        <p:nvSpPr>
+          <p:cNvPr id="17" name="Text 11"/>
           <p:cNvSpPr txBox="1"/>
           <p:nvPr/>
         </p:nvSpPr>
@@ -1345,7 +1358,7 @@
       </p:sp>
       <p:sp>
         <p:nvSpPr>
-          <p:cNvPr id="17" name="Text 12"/>
+          <p:cNvPr id="18" name="Text 12"/>
           <p:cNvSpPr txBox="1"/>
           <p:nvPr/>
         </p:nvSpPr>
@@ -1384,7 +1397,7 @@
       </p:sp>
       <p:sp>
         <p:nvSpPr>
-          <p:cNvPr id="18" name="Nome do Convidado"/>
+          <p:cNvPr id="19" name="Nome do Convidado"/>
           <p:cNvSpPr txBox="1"/>
           <p:nvPr/>
         </p:nvSpPr>
@@ -1425,7 +1438,7 @@
       </p:sp>
       <p:sp>
         <p:nvSpPr>
-          <p:cNvPr id="19" name="Shape 14"/>
+          <p:cNvPr id="20" name="Shape 14"/>
           <p:cNvSpPr/>
           <p:nvPr/>
         </p:nvSpPr>
@@ -1450,7 +1463,7 @@
       </p:sp>
       <p:sp>
         <p:nvSpPr>
-          <p:cNvPr id="20" name="Text 15"/>
+          <p:cNvPr id="21" name="Text 15"/>
           <p:cNvSpPr txBox="1"/>
           <p:nvPr/>
         </p:nvSpPr>
@@ -1489,7 +1502,7 @@
       </p:sp>
       <p:sp>
         <p:nvSpPr>
-          <p:cNvPr id="21" name="Text 16"/>
+          <p:cNvPr id="22" name="Text 16"/>
           <p:cNvSpPr txBox="1"/>
           <p:nvPr/>
         </p:nvSpPr>
@@ -1528,7 +1541,7 @@
       </p:sp>
       <p:sp>
         <p:nvSpPr>
-          <p:cNvPr id="22" name="Text 17"/>
+          <p:cNvPr id="23" name="Text 17"/>
           <p:cNvSpPr txBox="1"/>
           <p:nvPr/>
         </p:nvSpPr>
@@ -1567,7 +1580,7 @@
       </p:sp>
       <p:sp>
         <p:nvSpPr>
-          <p:cNvPr id="23" name="Shape 18"/>
+          <p:cNvPr id="24" name="Shape 18"/>
           <p:cNvSpPr/>
           <p:nvPr/>
         </p:nvSpPr>
@@ -1594,7 +1607,7 @@
       </p:sp>
       <p:sp>
         <p:nvSpPr>
-          <p:cNvPr id="24" name="Shape 19"/>
+          <p:cNvPr id="25" name="Shape 19"/>
           <p:cNvSpPr/>
           <p:nvPr/>
         </p:nvSpPr>
@@ -1607,14 +1620,14 @@
             <a:avLst/>
           </a:prstGeom>
           <a:solidFill>
-            <a:srgbClr val="E30613"/>
+            <a:srgbClr val="E84910"/>
           </a:solidFill>
           <a:ln/>
         </p:spPr>
       </p:sp>
       <p:sp>
         <p:nvSpPr>
-          <p:cNvPr id="25" name="Text 20"/>
+          <p:cNvPr id="26" name="Text 20"/>
           <p:cNvSpPr txBox="1"/>
           <p:nvPr/>
         </p:nvSpPr>
@@ -1676,7 +1689,7 @@
       </p:sp>
       <p:sp>
         <p:nvSpPr>
-          <p:cNvPr id="26" name="Text 21"/>
+          <p:cNvPr id="27" name="Text 21"/>
           <p:cNvSpPr txBox="1"/>
           <p:nvPr/>
         </p:nvSpPr>
@@ -1715,14 +1728,14 @@
       </p:sp>
       <p:pic>
         <p:nvPicPr>
-          <p:cNvPr id="27" name="Image 3" descr="Código de barras decorativo">    </p:cNvPr>
+          <p:cNvPr id="28" name="Image 4" descr="Código de barras decorativo">    </p:cNvPr>
           <p:cNvPicPr>
             <a:picLocks noChangeAspect="1"/>
           </p:cNvPicPr>
           <p:nvPr/>
         </p:nvPicPr>
         <p:blipFill>
-          <a:blip r:embed="rId5"/>
+          <a:blip r:embed="rId6"/>
           <a:stretch>
             <a:fillRect/>
           </a:stretch>
@@ -1739,7 +1752,7 @@
       </p:pic>
       <p:sp>
         <p:nvSpPr>
-          <p:cNvPr id="28" name="Text 22"/>
+          <p:cNvPr id="29" name="Text 22"/>
           <p:cNvSpPr txBox="1"/>
           <p:nvPr/>
         </p:nvSpPr>
@@ -1879,7 +1892,7 @@
           </a:prstGeom>
           <a:ln w="22225">
             <a:solidFill>
-              <a:srgbClr val="E30613"/>
+              <a:srgbClr val="E84910"/>
             </a:solidFill>
             <a:prstDash val="solid"/>
           </a:ln>
@@ -1901,7 +1914,7 @@
           </a:prstGeom>
           <a:ln w="15875">
             <a:solidFill>
-              <a:srgbClr val="E30613"/>
+              <a:srgbClr val="E84910"/>
             </a:solidFill>
             <a:prstDash val="solid"/>
           </a:ln>
@@ -1923,7 +1936,7 @@
           </a:prstGeom>
           <a:ln w="12700">
             <a:solidFill>
-              <a:srgbClr val="E30613"/>
+              <a:srgbClr val="E84910"/>
             </a:solidFill>
             <a:prstDash val="solid"/>
           </a:ln>
@@ -1944,7 +1957,7 @@
             <a:avLst/>
           </a:prstGeom>
           <a:solidFill>
-            <a:srgbClr val="E30613"/>
+            <a:srgbClr val="E84910"/>
           </a:solidFill>
           <a:ln/>
         </p:spPr>
@@ -1965,7 +1978,7 @@
           </a:prstGeom>
           <a:ln w="22225">
             <a:solidFill>
-              <a:srgbClr val="E30613"/>
+              <a:srgbClr val="E84910"/>
             </a:solidFill>
             <a:prstDash val="solid"/>
           </a:ln>
@@ -1987,7 +2000,7 @@
           </a:prstGeom>
           <a:ln w="15875">
             <a:solidFill>
-              <a:srgbClr val="E30613"/>
+              <a:srgbClr val="E84910"/>
             </a:solidFill>
             <a:prstDash val="solid"/>
           </a:ln>
@@ -2009,7 +2022,7 @@
           </a:prstGeom>
           <a:ln w="12700">
             <a:solidFill>
-              <a:srgbClr val="E30613"/>
+              <a:srgbClr val="E84910"/>
             </a:solidFill>
             <a:prstDash val="solid"/>
           </a:ln>
@@ -2030,7 +2043,7 @@
             <a:avLst/>
           </a:prstGeom>
           <a:solidFill>
-            <a:srgbClr val="E30613"/>
+            <a:srgbClr val="E84910"/>
           </a:solidFill>
           <a:ln/>
         </p:spPr>
@@ -2051,7 +2064,7 @@
           </a:prstGeom>
           <a:ln w="22225">
             <a:solidFill>
-              <a:srgbClr val="E30613"/>
+              <a:srgbClr val="E84910"/>
             </a:solidFill>
             <a:prstDash val="solid"/>
           </a:ln>
@@ -2073,7 +2086,7 @@
           </a:prstGeom>
           <a:ln w="15875">
             <a:solidFill>
-              <a:srgbClr val="E30613"/>
+              <a:srgbClr val="E84910"/>
             </a:solidFill>
             <a:prstDash val="solid"/>
           </a:ln>
@@ -2095,7 +2108,7 @@
           </a:prstGeom>
           <a:ln w="12700">
             <a:solidFill>
-              <a:srgbClr val="E30613"/>
+              <a:srgbClr val="E84910"/>
             </a:solidFill>
             <a:prstDash val="solid"/>
           </a:ln>
@@ -2116,7 +2129,7 @@
             <a:avLst/>
           </a:prstGeom>
           <a:solidFill>
-            <a:srgbClr val="E30613"/>
+            <a:srgbClr val="E84910"/>
           </a:solidFill>
           <a:ln/>
         </p:spPr>
@@ -2137,7 +2150,7 @@
           </a:prstGeom>
           <a:ln w="22225">
             <a:solidFill>
-              <a:srgbClr val="E30613"/>
+              <a:srgbClr val="E84910"/>
             </a:solidFill>
             <a:prstDash val="solid"/>
           </a:ln>
@@ -2159,7 +2172,7 @@
           </a:prstGeom>
           <a:ln w="15875">
             <a:solidFill>
-              <a:srgbClr val="E30613"/>
+              <a:srgbClr val="E84910"/>
             </a:solidFill>
             <a:prstDash val="solid"/>
           </a:ln>
@@ -2181,7 +2194,7 @@
           </a:prstGeom>
           <a:ln w="12700">
             <a:solidFill>
-              <a:srgbClr val="E30613"/>
+              <a:srgbClr val="E84910"/>
             </a:solidFill>
             <a:prstDash val="solid"/>
           </a:ln>
@@ -2202,184 +2215,14 @@
             <a:avLst/>
           </a:prstGeom>
           <a:solidFill>
-            <a:srgbClr val="E30613"/>
-          </a:solidFill>
-          <a:ln/>
-        </p:spPr>
-      </p:sp>
-      <p:sp>
-        <p:nvSpPr>
-          <p:cNvPr id="20" name="Text 18"/>
-          <p:cNvSpPr txBox="1"/>
-          <p:nvPr/>
-        </p:nvSpPr>
-        <p:spPr>
-          <a:xfrm>
-            <a:off x="5318608" y="109728"/>
-            <a:ext cx="1554480" cy="347472"/>
-          </a:xfrm>
-          <a:prstGeom prst="rect">
-            <a:avLst/>
-          </a:prstGeom>
-          <a:solidFill>
-            <a:srgbClr val="E30613"/>
-          </a:solidFill>
-          <a:ln/>
-        </p:spPr>
-        <p:txBody>
-          <a:bodyPr wrap="square" lIns="0" tIns="0" rIns="0" bIns="0" rtlCol="0" anchor="ctr"/>
-          <a:lstStyle/>
-          <a:p>
-            <a:pPr algn="ctr" indent="0" marL="0">
-              <a:buNone/>
-            </a:pPr>
-            <a:r>
-              <a:rPr lang="en-US" sz="1800" b="1" i="1" spc="300" kern="0" dirty="0">
-                <a:solidFill>
-                  <a:srgbClr val="FFFFFF"/>
-                </a:solidFill>
-                <a:latin typeface="Arial" pitchFamily="34" charset="0"/>
-                <a:ea typeface="Arial" pitchFamily="34" charset="-122"/>
-                <a:cs typeface="Arial" pitchFamily="34" charset="-120"/>
-              </a:rPr>
-              <a:t>SENAI</a:t>
-            </a:r>
-            <a:endParaRPr lang="en-US" sz="1800" dirty="0"/>
-          </a:p>
-        </p:txBody>
-      </p:sp>
-      <p:sp>
-        <p:nvSpPr>
-          <p:cNvPr id="21" name="Text 19"/>
-          <p:cNvSpPr txBox="1"/>
-          <p:nvPr/>
-        </p:nvSpPr>
-        <p:spPr>
-          <a:xfrm>
-            <a:off x="1371600" y="658368"/>
-            <a:ext cx="9448495" cy="566928"/>
-          </a:xfrm>
-          <a:prstGeom prst="rect">
-            <a:avLst/>
-          </a:prstGeom>
-          <a:noFill/>
-          <a:ln/>
-        </p:spPr>
-        <p:txBody>
-          <a:bodyPr wrap="square" lIns="0" tIns="0" rIns="0" bIns="0" rtlCol="0" anchor="ctr"/>
-          <a:lstStyle/>
-          <a:p>
-            <a:pPr algn="ctr" indent="0" marL="0">
-              <a:buNone/>
-            </a:pPr>
-            <a:r>
-              <a:rPr lang="en-US" sz="3400" b="1" spc="400" kern="0" dirty="0">
-                <a:solidFill>
-                  <a:srgbClr val="FFFFFF"/>
-                </a:solidFill>
-                <a:latin typeface="Arial" pitchFamily="34" charset="0"/>
-                <a:ea typeface="Arial" pitchFamily="34" charset="-122"/>
-                <a:cs typeface="Arial" pitchFamily="34" charset="-120"/>
-              </a:rPr>
-              <a:t>O QUE VAMOS ABORDAR</a:t>
-            </a:r>
-            <a:endParaRPr lang="en-US" sz="3400" dirty="0"/>
-          </a:p>
-        </p:txBody>
-      </p:sp>
-      <p:sp>
-        <p:nvSpPr>
-          <p:cNvPr id="22" name="Text 20"/>
-          <p:cNvSpPr txBox="1"/>
-          <p:nvPr/>
-        </p:nvSpPr>
-        <p:spPr>
-          <a:xfrm>
-            <a:off x="1371600" y="1243584"/>
-            <a:ext cx="9448495" cy="310896"/>
-          </a:xfrm>
-          <a:prstGeom prst="rect">
-            <a:avLst/>
-          </a:prstGeom>
-          <a:noFill/>
-          <a:ln/>
-        </p:spPr>
-        <p:txBody>
-          <a:bodyPr wrap="square" lIns="0" tIns="0" rIns="0" bIns="0" rtlCol="0" anchor="ctr"/>
-          <a:lstStyle/>
-          <a:p>
-            <a:pPr algn="ctr" indent="0" marL="0">
-              <a:buNone/>
-            </a:pPr>
-            <a:r>
-              <a:rPr lang="en-US" sz="1600" i="1" dirty="0">
-                <a:solidFill>
-                  <a:srgbClr val="CADCFC"/>
-                </a:solidFill>
-                <a:latin typeface="Calibri" pitchFamily="34" charset="0"/>
-                <a:ea typeface="Calibri" pitchFamily="34" charset="-122"/>
-                <a:cs typeface="Calibri" pitchFamily="34" charset="-120"/>
-              </a:rPr>
-              <a:t>Seminário Almoxarifado em Foco — um panorama das principais áreas do almoxarifado</a:t>
-            </a:r>
-            <a:endParaRPr lang="en-US" sz="1600" dirty="0"/>
-          </a:p>
-        </p:txBody>
-      </p:sp>
-      <p:sp>
-        <p:nvSpPr>
-          <p:cNvPr id="23" name="Shape 21"/>
-          <p:cNvSpPr/>
-          <p:nvPr/>
-        </p:nvSpPr>
-        <p:spPr>
-          <a:xfrm>
-            <a:off x="883768" y="1828800"/>
-            <a:ext cx="3291840" cy="1828800"/>
-          </a:xfrm>
-          <a:prstGeom prst="roundRect">
-            <a:avLst>
-              <a:gd name="adj" fmla="val 5000"/>
-            </a:avLst>
-          </a:prstGeom>
-          <a:solidFill>
-            <a:srgbClr val="FFFFFF">
-              <a:alpha val="9000"/>
-            </a:srgbClr>
-          </a:solidFill>
-          <a:ln w="9525">
-            <a:solidFill>
-              <a:srgbClr val="9DB8E8">
-                <a:alpha val="45000"/>
-              </a:srgbClr>
-            </a:solidFill>
-            <a:prstDash val="solid"/>
-          </a:ln>
-        </p:spPr>
-      </p:sp>
-      <p:sp>
-        <p:nvSpPr>
-          <p:cNvPr id="24" name="Shape 22"/>
-          <p:cNvSpPr/>
-          <p:nvPr/>
-        </p:nvSpPr>
-        <p:spPr>
-          <a:xfrm>
-            <a:off x="1139800" y="2084832"/>
-            <a:ext cx="603504" cy="603504"/>
-          </a:xfrm>
-          <a:prstGeom prst="ellipse">
-            <a:avLst/>
-          </a:prstGeom>
-          <a:solidFill>
-            <a:srgbClr val="E30613"/>
+            <a:srgbClr val="E84910"/>
           </a:solidFill>
           <a:ln/>
         </p:spPr>
       </p:sp>
       <p:pic>
         <p:nvPicPr>
-          <p:cNvPr id="25" name="Image 0" descr="Recebimento">    </p:cNvPr>
+          <p:cNvPr id="20" name="Image 0" descr="Logo SENAI">    </p:cNvPr>
           <p:cNvPicPr>
             <a:picLocks noChangeAspect="1"/>
           </p:cNvPicPr>
@@ -2393,896 +2236,14 @@
         </p:blipFill>
         <p:spPr>
           <a:xfrm>
-            <a:off x="1276960" y="2221992"/>
-            <a:ext cx="329184" cy="329184"/>
+            <a:off x="3718408" y="2805379"/>
+            <a:ext cx="4754880" cy="1247242"/>
           </a:xfrm>
           <a:prstGeom prst="rect">
             <a:avLst/>
           </a:prstGeom>
         </p:spPr>
       </p:pic>
-      <p:sp>
-        <p:nvSpPr>
-          <p:cNvPr id="26" name="Text 23"/>
-          <p:cNvSpPr txBox="1"/>
-          <p:nvPr/>
-        </p:nvSpPr>
-        <p:spPr>
-          <a:xfrm>
-            <a:off x="1889608" y="2066544"/>
-            <a:ext cx="2103120" cy="640080"/>
-          </a:xfrm>
-          <a:prstGeom prst="rect">
-            <a:avLst/>
-          </a:prstGeom>
-          <a:noFill/>
-          <a:ln/>
-        </p:spPr>
-        <p:txBody>
-          <a:bodyPr wrap="square" lIns="0" tIns="0" rIns="0" bIns="0" rtlCol="0" anchor="ctr"/>
-          <a:lstStyle/>
-          <a:p>
-            <a:pPr indent="0" marL="0">
-              <a:buNone/>
-            </a:pPr>
-            <a:r>
-              <a:rPr lang="en-US" sz="1600" b="1" dirty="0">
-                <a:solidFill>
-                  <a:srgbClr val="FFFFFF"/>
-                </a:solidFill>
-                <a:latin typeface="Arial" pitchFamily="34" charset="0"/>
-                <a:ea typeface="Arial" pitchFamily="34" charset="-122"/>
-                <a:cs typeface="Arial" pitchFamily="34" charset="-120"/>
-              </a:rPr>
-              <a:t>Recebimento</a:t>
-            </a:r>
-            <a:endParaRPr lang="en-US" sz="1600" dirty="0"/>
-          </a:p>
-        </p:txBody>
-      </p:sp>
-      <p:sp>
-        <p:nvSpPr>
-          <p:cNvPr id="27" name="Text 24"/>
-          <p:cNvSpPr txBox="1"/>
-          <p:nvPr/>
-        </p:nvSpPr>
-        <p:spPr>
-          <a:xfrm>
-            <a:off x="1139800" y="2834640"/>
-            <a:ext cx="2779776" cy="658368"/>
-          </a:xfrm>
-          <a:prstGeom prst="rect">
-            <a:avLst/>
-          </a:prstGeom>
-          <a:noFill/>
-          <a:ln/>
-        </p:spPr>
-        <p:txBody>
-          <a:bodyPr wrap="square" lIns="0" tIns="0" rIns="0" bIns="0" rtlCol="0" anchor="t"/>
-          <a:lstStyle/>
-          <a:p>
-            <a:pPr indent="0" marL="0">
-              <a:buNone/>
-            </a:pPr>
-            <a:r>
-              <a:rPr lang="en-US" sz="1350" dirty="0">
-                <a:solidFill>
-                  <a:srgbClr val="D5E2FA"/>
-                </a:solidFill>
-                <a:latin typeface="Calibri" pitchFamily="34" charset="0"/>
-                <a:ea typeface="Calibri" pitchFamily="34" charset="-122"/>
-                <a:cs typeface="Calibri" pitchFamily="34" charset="-120"/>
-              </a:rPr>
-              <a:t>Conferência de notas fiscais, inspeção de quantidade e qualidade e registro de entrada.</a:t>
-            </a:r>
-            <a:endParaRPr lang="en-US" sz="1350" dirty="0"/>
-          </a:p>
-        </p:txBody>
-      </p:sp>
-      <p:sp>
-        <p:nvSpPr>
-          <p:cNvPr id="28" name="Shape 25"/>
-          <p:cNvSpPr/>
-          <p:nvPr/>
-        </p:nvSpPr>
-        <p:spPr>
-          <a:xfrm>
-            <a:off x="4449928" y="1828800"/>
-            <a:ext cx="3291840" cy="1828800"/>
-          </a:xfrm>
-          <a:prstGeom prst="roundRect">
-            <a:avLst>
-              <a:gd name="adj" fmla="val 5000"/>
-            </a:avLst>
-          </a:prstGeom>
-          <a:solidFill>
-            <a:srgbClr val="FFFFFF">
-              <a:alpha val="9000"/>
-            </a:srgbClr>
-          </a:solidFill>
-          <a:ln w="9525">
-            <a:solidFill>
-              <a:srgbClr val="9DB8E8">
-                <a:alpha val="45000"/>
-              </a:srgbClr>
-            </a:solidFill>
-            <a:prstDash val="solid"/>
-          </a:ln>
-        </p:spPr>
-      </p:sp>
-      <p:sp>
-        <p:nvSpPr>
-          <p:cNvPr id="29" name="Shape 26"/>
-          <p:cNvSpPr/>
-          <p:nvPr/>
-        </p:nvSpPr>
-        <p:spPr>
-          <a:xfrm>
-            <a:off x="4705960" y="2084832"/>
-            <a:ext cx="603504" cy="603504"/>
-          </a:xfrm>
-          <a:prstGeom prst="ellipse">
-            <a:avLst/>
-          </a:prstGeom>
-          <a:solidFill>
-            <a:srgbClr val="E30613"/>
-          </a:solidFill>
-          <a:ln/>
-        </p:spPr>
-      </p:sp>
-      <p:pic>
-        <p:nvPicPr>
-          <p:cNvPr id="30" name="Image 1" descr="Armazenagem">    </p:cNvPr>
-          <p:cNvPicPr>
-            <a:picLocks noChangeAspect="1"/>
-          </p:cNvPicPr>
-          <p:nvPr/>
-        </p:nvPicPr>
-        <p:blipFill>
-          <a:blip r:embed="rId3"/>
-          <a:stretch>
-            <a:fillRect/>
-          </a:stretch>
-        </p:blipFill>
-        <p:spPr>
-          <a:xfrm>
-            <a:off x="4843120" y="2221992"/>
-            <a:ext cx="329184" cy="329184"/>
-          </a:xfrm>
-          <a:prstGeom prst="rect">
-            <a:avLst/>
-          </a:prstGeom>
-        </p:spPr>
-      </p:pic>
-      <p:sp>
-        <p:nvSpPr>
-          <p:cNvPr id="31" name="Text 27"/>
-          <p:cNvSpPr txBox="1"/>
-          <p:nvPr/>
-        </p:nvSpPr>
-        <p:spPr>
-          <a:xfrm>
-            <a:off x="5455768" y="2066544"/>
-            <a:ext cx="2103120" cy="640080"/>
-          </a:xfrm>
-          <a:prstGeom prst="rect">
-            <a:avLst/>
-          </a:prstGeom>
-          <a:noFill/>
-          <a:ln/>
-        </p:spPr>
-        <p:txBody>
-          <a:bodyPr wrap="square" lIns="0" tIns="0" rIns="0" bIns="0" rtlCol="0" anchor="ctr"/>
-          <a:lstStyle/>
-          <a:p>
-            <a:pPr indent="0" marL="0">
-              <a:buNone/>
-            </a:pPr>
-            <a:r>
-              <a:rPr lang="en-US" sz="1600" b="1" dirty="0">
-                <a:solidFill>
-                  <a:srgbClr val="FFFFFF"/>
-                </a:solidFill>
-                <a:latin typeface="Arial" pitchFamily="34" charset="0"/>
-                <a:ea typeface="Arial" pitchFamily="34" charset="-122"/>
-                <a:cs typeface="Arial" pitchFamily="34" charset="-120"/>
-              </a:rPr>
-              <a:t>Armazenagem</a:t>
-            </a:r>
-            <a:endParaRPr lang="en-US" sz="1600" dirty="0"/>
-          </a:p>
-        </p:txBody>
-      </p:sp>
-      <p:sp>
-        <p:nvSpPr>
-          <p:cNvPr id="32" name="Text 28"/>
-          <p:cNvSpPr txBox="1"/>
-          <p:nvPr/>
-        </p:nvSpPr>
-        <p:spPr>
-          <a:xfrm>
-            <a:off x="4705960" y="2834640"/>
-            <a:ext cx="2779776" cy="658368"/>
-          </a:xfrm>
-          <a:prstGeom prst="rect">
-            <a:avLst/>
-          </a:prstGeom>
-          <a:noFill/>
-          <a:ln/>
-        </p:spPr>
-        <p:txBody>
-          <a:bodyPr wrap="square" lIns="0" tIns="0" rIns="0" bIns="0" rtlCol="0" anchor="t"/>
-          <a:lstStyle/>
-          <a:p>
-            <a:pPr indent="0" marL="0">
-              <a:buNone/>
-            </a:pPr>
-            <a:r>
-              <a:rPr lang="en-US" sz="1350" dirty="0">
-                <a:solidFill>
-                  <a:srgbClr val="D5E2FA"/>
-                </a:solidFill>
-                <a:latin typeface="Calibri" pitchFamily="34" charset="0"/>
-                <a:ea typeface="Calibri" pitchFamily="34" charset="-122"/>
-                <a:cs typeface="Calibri" pitchFamily="34" charset="-120"/>
-              </a:rPr>
-              <a:t>Layout, endereçamento, empilhamento seguro e conservação dos materiais.</a:t>
-            </a:r>
-            <a:endParaRPr lang="en-US" sz="1350" dirty="0"/>
-          </a:p>
-        </p:txBody>
-      </p:sp>
-      <p:sp>
-        <p:nvSpPr>
-          <p:cNvPr id="33" name="Shape 29"/>
-          <p:cNvSpPr/>
-          <p:nvPr/>
-        </p:nvSpPr>
-        <p:spPr>
-          <a:xfrm>
-            <a:off x="8016088" y="1828800"/>
-            <a:ext cx="3291840" cy="1828800"/>
-          </a:xfrm>
-          <a:prstGeom prst="roundRect">
-            <a:avLst>
-              <a:gd name="adj" fmla="val 5000"/>
-            </a:avLst>
-          </a:prstGeom>
-          <a:solidFill>
-            <a:srgbClr val="FFFFFF">
-              <a:alpha val="9000"/>
-            </a:srgbClr>
-          </a:solidFill>
-          <a:ln w="9525">
-            <a:solidFill>
-              <a:srgbClr val="9DB8E8">
-                <a:alpha val="45000"/>
-              </a:srgbClr>
-            </a:solidFill>
-            <a:prstDash val="solid"/>
-          </a:ln>
-        </p:spPr>
-      </p:sp>
-      <p:sp>
-        <p:nvSpPr>
-          <p:cNvPr id="34" name="Shape 30"/>
-          <p:cNvSpPr/>
-          <p:nvPr/>
-        </p:nvSpPr>
-        <p:spPr>
-          <a:xfrm>
-            <a:off x="8272120" y="2084832"/>
-            <a:ext cx="603504" cy="603504"/>
-          </a:xfrm>
-          <a:prstGeom prst="ellipse">
-            <a:avLst/>
-          </a:prstGeom>
-          <a:solidFill>
-            <a:srgbClr val="E30613"/>
-          </a:solidFill>
-          <a:ln/>
-        </p:spPr>
-      </p:sp>
-      <p:pic>
-        <p:nvPicPr>
-          <p:cNvPr id="35" name="Image 2" descr="Controle de Estoque">    </p:cNvPr>
-          <p:cNvPicPr>
-            <a:picLocks noChangeAspect="1"/>
-          </p:cNvPicPr>
-          <p:nvPr/>
-        </p:nvPicPr>
-        <p:blipFill>
-          <a:blip r:embed="rId4"/>
-          <a:stretch>
-            <a:fillRect/>
-          </a:stretch>
-        </p:blipFill>
-        <p:spPr>
-          <a:xfrm>
-            <a:off x="8409280" y="2221992"/>
-            <a:ext cx="329184" cy="329184"/>
-          </a:xfrm>
-          <a:prstGeom prst="rect">
-            <a:avLst/>
-          </a:prstGeom>
-        </p:spPr>
-      </p:pic>
-      <p:sp>
-        <p:nvSpPr>
-          <p:cNvPr id="36" name="Text 31"/>
-          <p:cNvSpPr txBox="1"/>
-          <p:nvPr/>
-        </p:nvSpPr>
-        <p:spPr>
-          <a:xfrm>
-            <a:off x="9021928" y="2066544"/>
-            <a:ext cx="2103120" cy="640080"/>
-          </a:xfrm>
-          <a:prstGeom prst="rect">
-            <a:avLst/>
-          </a:prstGeom>
-          <a:noFill/>
-          <a:ln/>
-        </p:spPr>
-        <p:txBody>
-          <a:bodyPr wrap="square" lIns="0" tIns="0" rIns="0" bIns="0" rtlCol="0" anchor="ctr"/>
-          <a:lstStyle/>
-          <a:p>
-            <a:pPr indent="0" marL="0">
-              <a:buNone/>
-            </a:pPr>
-            <a:r>
-              <a:rPr lang="en-US" sz="1600" b="1" dirty="0">
-                <a:solidFill>
-                  <a:srgbClr val="FFFFFF"/>
-                </a:solidFill>
-                <a:latin typeface="Arial" pitchFamily="34" charset="0"/>
-                <a:ea typeface="Arial" pitchFamily="34" charset="-122"/>
-                <a:cs typeface="Arial" pitchFamily="34" charset="-120"/>
-              </a:rPr>
-              <a:t>Controle de Estoque</a:t>
-            </a:r>
-            <a:endParaRPr lang="en-US" sz="1600" dirty="0"/>
-          </a:p>
-        </p:txBody>
-      </p:sp>
-      <p:sp>
-        <p:nvSpPr>
-          <p:cNvPr id="37" name="Text 32"/>
-          <p:cNvSpPr txBox="1"/>
-          <p:nvPr/>
-        </p:nvSpPr>
-        <p:spPr>
-          <a:xfrm>
-            <a:off x="8272120" y="2834640"/>
-            <a:ext cx="2779776" cy="658368"/>
-          </a:xfrm>
-          <a:prstGeom prst="rect">
-            <a:avLst/>
-          </a:prstGeom>
-          <a:noFill/>
-          <a:ln/>
-        </p:spPr>
-        <p:txBody>
-          <a:bodyPr wrap="square" lIns="0" tIns="0" rIns="0" bIns="0" rtlCol="0" anchor="t"/>
-          <a:lstStyle/>
-          <a:p>
-            <a:pPr indent="0" marL="0">
-              <a:buNone/>
-            </a:pPr>
-            <a:r>
-              <a:rPr lang="en-US" sz="1350" dirty="0">
-                <a:solidFill>
-                  <a:srgbClr val="D5E2FA"/>
-                </a:solidFill>
-                <a:latin typeface="Calibri" pitchFamily="34" charset="0"/>
-                <a:ea typeface="Calibri" pitchFamily="34" charset="-122"/>
-                <a:cs typeface="Calibri" pitchFamily="34" charset="-120"/>
-              </a:rPr>
-              <a:t>Curva ABC, PEPS/FIFO, estoque mínimo e máximo e ponto de pedido.</a:t>
-            </a:r>
-            <a:endParaRPr lang="en-US" sz="1350" dirty="0"/>
-          </a:p>
-        </p:txBody>
-      </p:sp>
-      <p:sp>
-        <p:nvSpPr>
-          <p:cNvPr id="38" name="Shape 33"/>
-          <p:cNvSpPr/>
-          <p:nvPr/>
-        </p:nvSpPr>
-        <p:spPr>
-          <a:xfrm>
-            <a:off x="883768" y="3931920"/>
-            <a:ext cx="3291840" cy="1828800"/>
-          </a:xfrm>
-          <a:prstGeom prst="roundRect">
-            <a:avLst>
-              <a:gd name="adj" fmla="val 5000"/>
-            </a:avLst>
-          </a:prstGeom>
-          <a:solidFill>
-            <a:srgbClr val="FFFFFF">
-              <a:alpha val="9000"/>
-            </a:srgbClr>
-          </a:solidFill>
-          <a:ln w="9525">
-            <a:solidFill>
-              <a:srgbClr val="9DB8E8">
-                <a:alpha val="45000"/>
-              </a:srgbClr>
-            </a:solidFill>
-            <a:prstDash val="solid"/>
-          </a:ln>
-        </p:spPr>
-      </p:sp>
-      <p:sp>
-        <p:nvSpPr>
-          <p:cNvPr id="39" name="Shape 34"/>
-          <p:cNvSpPr/>
-          <p:nvPr/>
-        </p:nvSpPr>
-        <p:spPr>
-          <a:xfrm>
-            <a:off x="1139800" y="4187952"/>
-            <a:ext cx="603504" cy="603504"/>
-          </a:xfrm>
-          <a:prstGeom prst="ellipse">
-            <a:avLst/>
-          </a:prstGeom>
-          <a:solidFill>
-            <a:srgbClr val="E30613"/>
-          </a:solidFill>
-          <a:ln/>
-        </p:spPr>
-      </p:sp>
-      <p:pic>
-        <p:nvPicPr>
-          <p:cNvPr id="40" name="Image 3" descr="Inventário">    </p:cNvPr>
-          <p:cNvPicPr>
-            <a:picLocks noChangeAspect="1"/>
-          </p:cNvPicPr>
-          <p:nvPr/>
-        </p:nvPicPr>
-        <p:blipFill>
-          <a:blip r:embed="rId5"/>
-          <a:stretch>
-            <a:fillRect/>
-          </a:stretch>
-        </p:blipFill>
-        <p:spPr>
-          <a:xfrm>
-            <a:off x="1276960" y="4325112"/>
-            <a:ext cx="329184" cy="329184"/>
-          </a:xfrm>
-          <a:prstGeom prst="rect">
-            <a:avLst/>
-          </a:prstGeom>
-        </p:spPr>
-      </p:pic>
-      <p:sp>
-        <p:nvSpPr>
-          <p:cNvPr id="41" name="Text 35"/>
-          <p:cNvSpPr txBox="1"/>
-          <p:nvPr/>
-        </p:nvSpPr>
-        <p:spPr>
-          <a:xfrm>
-            <a:off x="1889608" y="4169664"/>
-            <a:ext cx="2103120" cy="640080"/>
-          </a:xfrm>
-          <a:prstGeom prst="rect">
-            <a:avLst/>
-          </a:prstGeom>
-          <a:noFill/>
-          <a:ln/>
-        </p:spPr>
-        <p:txBody>
-          <a:bodyPr wrap="square" lIns="0" tIns="0" rIns="0" bIns="0" rtlCol="0" anchor="ctr"/>
-          <a:lstStyle/>
-          <a:p>
-            <a:pPr indent="0" marL="0">
-              <a:buNone/>
-            </a:pPr>
-            <a:r>
-              <a:rPr lang="en-US" sz="1600" b="1" dirty="0">
-                <a:solidFill>
-                  <a:srgbClr val="FFFFFF"/>
-                </a:solidFill>
-                <a:latin typeface="Arial" pitchFamily="34" charset="0"/>
-                <a:ea typeface="Arial" pitchFamily="34" charset="-122"/>
-                <a:cs typeface="Arial" pitchFamily="34" charset="-120"/>
-              </a:rPr>
-              <a:t>Inventário</a:t>
-            </a:r>
-            <a:endParaRPr lang="en-US" sz="1600" dirty="0"/>
-          </a:p>
-        </p:txBody>
-      </p:sp>
-      <p:sp>
-        <p:nvSpPr>
-          <p:cNvPr id="42" name="Text 36"/>
-          <p:cNvSpPr txBox="1"/>
-          <p:nvPr/>
-        </p:nvSpPr>
-        <p:spPr>
-          <a:xfrm>
-            <a:off x="1139800" y="4937760"/>
-            <a:ext cx="2779776" cy="658368"/>
-          </a:xfrm>
-          <a:prstGeom prst="rect">
-            <a:avLst/>
-          </a:prstGeom>
-          <a:noFill/>
-          <a:ln/>
-        </p:spPr>
-        <p:txBody>
-          <a:bodyPr wrap="square" lIns="0" tIns="0" rIns="0" bIns="0" rtlCol="0" anchor="t"/>
-          <a:lstStyle/>
-          <a:p>
-            <a:pPr indent="0" marL="0">
-              <a:buNone/>
-            </a:pPr>
-            <a:r>
-              <a:rPr lang="en-US" sz="1350" dirty="0">
-                <a:solidFill>
-                  <a:srgbClr val="D5E2FA"/>
-                </a:solidFill>
-                <a:latin typeface="Calibri" pitchFamily="34" charset="0"/>
-                <a:ea typeface="Calibri" pitchFamily="34" charset="-122"/>
-                <a:cs typeface="Calibri" pitchFamily="34" charset="-120"/>
-              </a:rPr>
-              <a:t>Inventário periódico e rotativo, acuracidade e ajuste de divergências.</a:t>
-            </a:r>
-            <a:endParaRPr lang="en-US" sz="1350" dirty="0"/>
-          </a:p>
-        </p:txBody>
-      </p:sp>
-      <p:sp>
-        <p:nvSpPr>
-          <p:cNvPr id="43" name="Shape 37"/>
-          <p:cNvSpPr/>
-          <p:nvPr/>
-        </p:nvSpPr>
-        <p:spPr>
-          <a:xfrm>
-            <a:off x="4449928" y="3931920"/>
-            <a:ext cx="3291840" cy="1828800"/>
-          </a:xfrm>
-          <a:prstGeom prst="roundRect">
-            <a:avLst>
-              <a:gd name="adj" fmla="val 5000"/>
-            </a:avLst>
-          </a:prstGeom>
-          <a:solidFill>
-            <a:srgbClr val="FFFFFF">
-              <a:alpha val="9000"/>
-            </a:srgbClr>
-          </a:solidFill>
-          <a:ln w="9525">
-            <a:solidFill>
-              <a:srgbClr val="9DB8E8">
-                <a:alpha val="45000"/>
-              </a:srgbClr>
-            </a:solidFill>
-            <a:prstDash val="solid"/>
-          </a:ln>
-        </p:spPr>
-      </p:sp>
-      <p:sp>
-        <p:nvSpPr>
-          <p:cNvPr id="44" name="Shape 38"/>
-          <p:cNvSpPr/>
-          <p:nvPr/>
-        </p:nvSpPr>
-        <p:spPr>
-          <a:xfrm>
-            <a:off x="4705960" y="4187952"/>
-            <a:ext cx="603504" cy="603504"/>
-          </a:xfrm>
-          <a:prstGeom prst="ellipse">
-            <a:avLst/>
-          </a:prstGeom>
-          <a:solidFill>
-            <a:srgbClr val="E30613"/>
-          </a:solidFill>
-          <a:ln/>
-        </p:spPr>
-      </p:sp>
-      <p:pic>
-        <p:nvPicPr>
-          <p:cNvPr id="45" name="Image 4" descr="Movimentação e Expedição">    </p:cNvPr>
-          <p:cNvPicPr>
-            <a:picLocks noChangeAspect="1"/>
-          </p:cNvPicPr>
-          <p:nvPr/>
-        </p:nvPicPr>
-        <p:blipFill>
-          <a:blip r:embed="rId6"/>
-          <a:stretch>
-            <a:fillRect/>
-          </a:stretch>
-        </p:blipFill>
-        <p:spPr>
-          <a:xfrm>
-            <a:off x="4843120" y="4325112"/>
-            <a:ext cx="329184" cy="329184"/>
-          </a:xfrm>
-          <a:prstGeom prst="rect">
-            <a:avLst/>
-          </a:prstGeom>
-        </p:spPr>
-      </p:pic>
-      <p:sp>
-        <p:nvSpPr>
-          <p:cNvPr id="46" name="Text 39"/>
-          <p:cNvSpPr txBox="1"/>
-          <p:nvPr/>
-        </p:nvSpPr>
-        <p:spPr>
-          <a:xfrm>
-            <a:off x="5455768" y="4169664"/>
-            <a:ext cx="2103120" cy="640080"/>
-          </a:xfrm>
-          <a:prstGeom prst="rect">
-            <a:avLst/>
-          </a:prstGeom>
-          <a:noFill/>
-          <a:ln/>
-        </p:spPr>
-        <p:txBody>
-          <a:bodyPr wrap="square" lIns="0" tIns="0" rIns="0" bIns="0" rtlCol="0" anchor="ctr"/>
-          <a:lstStyle/>
-          <a:p>
-            <a:pPr indent="0" marL="0">
-              <a:buNone/>
-            </a:pPr>
-            <a:r>
-              <a:rPr lang="en-US" sz="1600" b="1" dirty="0">
-                <a:solidFill>
-                  <a:srgbClr val="FFFFFF"/>
-                </a:solidFill>
-                <a:latin typeface="Arial" pitchFamily="34" charset="0"/>
-                <a:ea typeface="Arial" pitchFamily="34" charset="-122"/>
-                <a:cs typeface="Arial" pitchFamily="34" charset="-120"/>
-              </a:rPr>
-              <a:t>Movimentação e Expedição</a:t>
-            </a:r>
-            <a:endParaRPr lang="en-US" sz="1600" dirty="0"/>
-          </a:p>
-        </p:txBody>
-      </p:sp>
-      <p:sp>
-        <p:nvSpPr>
-          <p:cNvPr id="47" name="Text 40"/>
-          <p:cNvSpPr txBox="1"/>
-          <p:nvPr/>
-        </p:nvSpPr>
-        <p:spPr>
-          <a:xfrm>
-            <a:off x="4705960" y="4937760"/>
-            <a:ext cx="2779776" cy="658368"/>
-          </a:xfrm>
-          <a:prstGeom prst="rect">
-            <a:avLst/>
-          </a:prstGeom>
-          <a:noFill/>
-          <a:ln/>
-        </p:spPr>
-        <p:txBody>
-          <a:bodyPr wrap="square" lIns="0" tIns="0" rIns="0" bIns="0" rtlCol="0" anchor="t"/>
-          <a:lstStyle/>
-          <a:p>
-            <a:pPr indent="0" marL="0">
-              <a:buNone/>
-            </a:pPr>
-            <a:r>
-              <a:rPr lang="en-US" sz="1350" dirty="0">
-                <a:solidFill>
-                  <a:srgbClr val="D5E2FA"/>
-                </a:solidFill>
-                <a:latin typeface="Calibri" pitchFamily="34" charset="0"/>
-                <a:ea typeface="Calibri" pitchFamily="34" charset="-122"/>
-                <a:cs typeface="Calibri" pitchFamily="34" charset="-120"/>
-              </a:rPr>
-              <a:t>Paleteiras e empilhadeiras, separação de pedidos, embalagem e distribuição.</a:t>
-            </a:r>
-            <a:endParaRPr lang="en-US" sz="1350" dirty="0"/>
-          </a:p>
-        </p:txBody>
-      </p:sp>
-      <p:sp>
-        <p:nvSpPr>
-          <p:cNvPr id="48" name="Shape 41"/>
-          <p:cNvSpPr/>
-          <p:nvPr/>
-        </p:nvSpPr>
-        <p:spPr>
-          <a:xfrm>
-            <a:off x="8016088" y="3931920"/>
-            <a:ext cx="3291840" cy="1828800"/>
-          </a:xfrm>
-          <a:prstGeom prst="roundRect">
-            <a:avLst>
-              <a:gd name="adj" fmla="val 5000"/>
-            </a:avLst>
-          </a:prstGeom>
-          <a:solidFill>
-            <a:srgbClr val="FFFFFF">
-              <a:alpha val="9000"/>
-            </a:srgbClr>
-          </a:solidFill>
-          <a:ln w="9525">
-            <a:solidFill>
-              <a:srgbClr val="9DB8E8">
-                <a:alpha val="45000"/>
-              </a:srgbClr>
-            </a:solidFill>
-            <a:prstDash val="solid"/>
-          </a:ln>
-        </p:spPr>
-      </p:sp>
-      <p:sp>
-        <p:nvSpPr>
-          <p:cNvPr id="49" name="Shape 42"/>
-          <p:cNvSpPr/>
-          <p:nvPr/>
-        </p:nvSpPr>
-        <p:spPr>
-          <a:xfrm>
-            <a:off x="8272120" y="4187952"/>
-            <a:ext cx="603504" cy="603504"/>
-          </a:xfrm>
-          <a:prstGeom prst="ellipse">
-            <a:avLst/>
-          </a:prstGeom>
-          <a:solidFill>
-            <a:srgbClr val="E30613"/>
-          </a:solidFill>
-          <a:ln/>
-        </p:spPr>
-      </p:sp>
-      <p:pic>
-        <p:nvPicPr>
-          <p:cNvPr id="50" name="Image 5" descr="Segurança e Tecnologia">    </p:cNvPr>
-          <p:cNvPicPr>
-            <a:picLocks noChangeAspect="1"/>
-          </p:cNvPicPr>
-          <p:nvPr/>
-        </p:nvPicPr>
-        <p:blipFill>
-          <a:blip r:embed="rId7"/>
-          <a:stretch>
-            <a:fillRect/>
-          </a:stretch>
-        </p:blipFill>
-        <p:spPr>
-          <a:xfrm>
-            <a:off x="8409280" y="4325112"/>
-            <a:ext cx="329184" cy="329184"/>
-          </a:xfrm>
-          <a:prstGeom prst="rect">
-            <a:avLst/>
-          </a:prstGeom>
-        </p:spPr>
-      </p:pic>
-      <p:sp>
-        <p:nvSpPr>
-          <p:cNvPr id="51" name="Text 43"/>
-          <p:cNvSpPr txBox="1"/>
-          <p:nvPr/>
-        </p:nvSpPr>
-        <p:spPr>
-          <a:xfrm>
-            <a:off x="9021928" y="4169664"/>
-            <a:ext cx="2103120" cy="640080"/>
-          </a:xfrm>
-          <a:prstGeom prst="rect">
-            <a:avLst/>
-          </a:prstGeom>
-          <a:noFill/>
-          <a:ln/>
-        </p:spPr>
-        <p:txBody>
-          <a:bodyPr wrap="square" lIns="0" tIns="0" rIns="0" bIns="0" rtlCol="0" anchor="ctr"/>
-          <a:lstStyle/>
-          <a:p>
-            <a:pPr indent="0" marL="0">
-              <a:buNone/>
-            </a:pPr>
-            <a:r>
-              <a:rPr lang="en-US" sz="1600" b="1" dirty="0">
-                <a:solidFill>
-                  <a:srgbClr val="FFFFFF"/>
-                </a:solidFill>
-                <a:latin typeface="Arial" pitchFamily="34" charset="0"/>
-                <a:ea typeface="Arial" pitchFamily="34" charset="-122"/>
-                <a:cs typeface="Arial" pitchFamily="34" charset="-120"/>
-              </a:rPr>
-              <a:t>Segurança e Tecnologia</a:t>
-            </a:r>
-            <a:endParaRPr lang="en-US" sz="1600" dirty="0"/>
-          </a:p>
-        </p:txBody>
-      </p:sp>
-      <p:sp>
-        <p:nvSpPr>
-          <p:cNvPr id="52" name="Text 44"/>
-          <p:cNvSpPr txBox="1"/>
-          <p:nvPr/>
-        </p:nvSpPr>
-        <p:spPr>
-          <a:xfrm>
-            <a:off x="8272120" y="4937760"/>
-            <a:ext cx="2779776" cy="658368"/>
-          </a:xfrm>
-          <a:prstGeom prst="rect">
-            <a:avLst/>
-          </a:prstGeom>
-          <a:noFill/>
-          <a:ln/>
-        </p:spPr>
-        <p:txBody>
-          <a:bodyPr wrap="square" lIns="0" tIns="0" rIns="0" bIns="0" rtlCol="0" anchor="t"/>
-          <a:lstStyle/>
-          <a:p>
-            <a:pPr indent="0" marL="0">
-              <a:buNone/>
-            </a:pPr>
-            <a:r>
-              <a:rPr lang="en-US" sz="1350" dirty="0">
-                <a:solidFill>
-                  <a:srgbClr val="D5E2FA"/>
-                </a:solidFill>
-                <a:latin typeface="Calibri" pitchFamily="34" charset="0"/>
-                <a:ea typeface="Calibri" pitchFamily="34" charset="-122"/>
-                <a:cs typeface="Calibri" pitchFamily="34" charset="-120"/>
-              </a:rPr>
-              <a:t>NR-11, uso de EPIs, sinalização, código de barras e sistemas WMS/ERP.</a:t>
-            </a:r>
-            <a:endParaRPr lang="en-US" sz="1350" dirty="0"/>
-          </a:p>
-        </p:txBody>
-      </p:sp>
-      <p:sp>
-        <p:nvSpPr>
-          <p:cNvPr id="53" name="Text 45"/>
-          <p:cNvSpPr txBox="1"/>
-          <p:nvPr/>
-        </p:nvSpPr>
-        <p:spPr>
-          <a:xfrm>
-            <a:off x="1828800" y="5961888"/>
-            <a:ext cx="8534095" cy="310896"/>
-          </a:xfrm>
-          <a:prstGeom prst="rect">
-            <a:avLst/>
-          </a:prstGeom>
-          <a:noFill/>
-          <a:ln/>
-        </p:spPr>
-        <p:txBody>
-          <a:bodyPr wrap="square" lIns="0" tIns="0" rIns="0" bIns="0" rtlCol="0" anchor="ctr"/>
-          <a:lstStyle/>
-          <a:p>
-            <a:pPr algn="ctr" indent="0" marL="0">
-              <a:buNone/>
-            </a:pPr>
-            <a:r>
-              <a:rPr lang="en-US" sz="1400" b="1" spc="400" kern="0" dirty="0">
-                <a:solidFill>
-                  <a:srgbClr val="CADCFC"/>
-                </a:solidFill>
-                <a:latin typeface="Arial" pitchFamily="34" charset="0"/>
-                <a:ea typeface="Arial" pitchFamily="34" charset="-122"/>
-                <a:cs typeface="Arial" pitchFamily="34" charset="-120"/>
-              </a:rPr>
-              <a:t>21 DE OUTUBRO  ·  QUARTA-FEIRA</a:t>
-            </a:r>
-            <a:endParaRPr lang="en-US" sz="1400" dirty="0"/>
-          </a:p>
-        </p:txBody>
-      </p:sp>
     </p:spTree>
   </p:cSld>
   <p:clrMapOvr>

</xml_diff>

<commit_message>
Convite: horário (14h30) e local do SENAI Paragominas
Etiqueta de data passa a mostrar o horário, e um bloco ao lado traz o
endereço: Rua Barão de Araruna, s/n – Promissão II – Paragominas/PA.

Co-Authored-By: Claude Opus 5.5 <noreply@anthropic.com>
Claude-Session: https://claude.ai/code/session_015fDDoufnzCV884FLxp7NTd
</commit_message>
<xml_diff>
--- a/convites/convite-seminario-almoxarifado-senai.pptx
+++ b/convites/convite-seminario-almoxarifado-senai.pptx
@@ -1586,8 +1586,8 @@
         </p:nvSpPr>
         <p:spPr>
           <a:xfrm>
-            <a:off x="4038448" y="4974336"/>
-            <a:ext cx="4114800" cy="841248"/>
+            <a:off x="2826868" y="4956048"/>
+            <a:ext cx="3200400" cy="868680"/>
           </a:xfrm>
           <a:prstGeom prst="rect">
             <a:avLst/>
@@ -1613,8 +1613,8 @@
         </p:nvSpPr>
         <p:spPr>
           <a:xfrm>
-            <a:off x="4038448" y="4974336"/>
-            <a:ext cx="1188720" cy="841248"/>
+            <a:off x="2826868" y="4956048"/>
+            <a:ext cx="960120" cy="868680"/>
           </a:xfrm>
           <a:prstGeom prst="rect">
             <a:avLst/>
@@ -1633,8 +1633,8 @@
         </p:nvSpPr>
         <p:spPr>
           <a:xfrm>
-            <a:off x="4038448" y="4992624"/>
-            <a:ext cx="1188720" cy="804672"/>
+            <a:off x="2826868" y="4974336"/>
+            <a:ext cx="960120" cy="832104"/>
           </a:xfrm>
           <a:prstGeom prst="rect">
             <a:avLst/>
@@ -1653,7 +1653,7 @@
               <a:buNone/>
             </a:pPr>
             <a:r>
-              <a:rPr lang="en-US" sz="3600" b="1" dirty="0">
+              <a:rPr lang="en-US" sz="3400" b="1" dirty="0">
                 <a:solidFill>
                   <a:srgbClr val="FFFFFF"/>
                 </a:solidFill>
@@ -1663,7 +1663,7 @@
               </a:rPr>
               <a:t>21</a:t>
             </a:r>
-            <a:endParaRPr lang="en-US" sz="3600" dirty="0"/>
+            <a:endParaRPr lang="en-US" sz="3400" dirty="0"/>
           </a:p>
           <a:p>
             <a:pPr algn="ctr" indent="0" marL="0">
@@ -1673,7 +1673,7 @@
               <a:buNone/>
             </a:pPr>
             <a:r>
-              <a:rPr lang="en-US" sz="1100" b="1" spc="200" kern="0" dirty="0">
+              <a:rPr lang="en-US" sz="1000" b="1" spc="150" kern="0" dirty="0">
                 <a:solidFill>
                   <a:srgbClr val="FFFFFF"/>
                 </a:solidFill>
@@ -1683,7 +1683,7 @@
               </a:rPr>
               <a:t>OUTUBRO</a:t>
             </a:r>
-            <a:endParaRPr lang="en-US" sz="3600" dirty="0"/>
+            <a:endParaRPr lang="en-US" sz="3400" dirty="0"/>
           </a:p>
         </p:txBody>
       </p:sp>
@@ -1695,8 +1695,8 @@
         </p:nvSpPr>
         <p:spPr>
           <a:xfrm>
-            <a:off x="5428336" y="5047488"/>
-            <a:ext cx="2560320" cy="384048"/>
+            <a:off x="3951580" y="5047488"/>
+            <a:ext cx="1783080" cy="310896"/>
           </a:xfrm>
           <a:prstGeom prst="rect">
             <a:avLst/>
@@ -1712,7 +1712,7 @@
               <a:buNone/>
             </a:pPr>
             <a:r>
-              <a:rPr lang="en-US" sz="2100" b="1" spc="300" kern="0" dirty="0">
+              <a:rPr lang="en-US" sz="1500" b="1" spc="100" kern="0" dirty="0">
                 <a:solidFill>
                   <a:srgbClr val="0E2A55"/>
                 </a:solidFill>
@@ -1722,13 +1722,13 @@
               </a:rPr>
               <a:t>QUARTA-FEIRA</a:t>
             </a:r>
-            <a:endParaRPr lang="en-US" sz="2100" dirty="0"/>
+            <a:endParaRPr lang="en-US" sz="1500" dirty="0"/>
           </a:p>
         </p:txBody>
       </p:sp>
       <p:pic>
         <p:nvPicPr>
-          <p:cNvPr id="28" name="Image 4" descr="Código de barras decorativo">    </p:cNvPr>
+          <p:cNvPr id="28" name="Image 4" descr="Relógio">    </p:cNvPr>
           <p:cNvPicPr>
             <a:picLocks noChangeAspect="1"/>
           </p:cNvPicPr>
@@ -1742,8 +1742,8 @@
         </p:blipFill>
         <p:spPr>
           <a:xfrm>
-            <a:off x="5428336" y="5477256"/>
-            <a:ext cx="2523744" cy="219456"/>
+            <a:off x="3951580" y="5449824"/>
+            <a:ext cx="246888" cy="246888"/>
           </a:xfrm>
           <a:prstGeom prst="rect">
             <a:avLst/>
@@ -1753,6 +1753,226 @@
       <p:sp>
         <p:nvSpPr>
           <p:cNvPr id="29" name="Text 22"/>
+          <p:cNvSpPr txBox="1"/>
+          <p:nvPr/>
+        </p:nvSpPr>
+        <p:spPr>
+          <a:xfrm>
+            <a:off x="4280764" y="5413248"/>
+            <a:ext cx="1463040" cy="329184"/>
+          </a:xfrm>
+          <a:prstGeom prst="rect">
+            <a:avLst/>
+          </a:prstGeom>
+          <a:noFill/>
+          <a:ln/>
+        </p:spPr>
+        <p:txBody>
+          <a:bodyPr wrap="square" lIns="0" tIns="0" rIns="0" bIns="0" rtlCol="0" anchor="ctr"/>
+          <a:lstStyle/>
+          <a:p>
+            <a:pPr algn="l" indent="0" marL="0">
+              <a:buNone/>
+            </a:pPr>
+            <a:r>
+              <a:rPr lang="en-US" sz="1800" b="1" dirty="0">
+                <a:solidFill>
+                  <a:srgbClr val="E84910"/>
+                </a:solidFill>
+                <a:latin typeface="Arial" pitchFamily="34" charset="0"/>
+                <a:ea typeface="Arial" pitchFamily="34" charset="-122"/>
+                <a:cs typeface="Arial" pitchFamily="34" charset="-120"/>
+              </a:rPr>
+              <a:t>ÀS 14H30</a:t>
+            </a:r>
+            <a:endParaRPr lang="en-US" sz="1800" dirty="0"/>
+          </a:p>
+        </p:txBody>
+      </p:sp>
+      <p:pic>
+        <p:nvPicPr>
+          <p:cNvPr id="30" name="Image 5" descr="Código de barras decorativo">    </p:cNvPr>
+          <p:cNvPicPr>
+            <a:picLocks noChangeAspect="1"/>
+          </p:cNvPicPr>
+          <p:nvPr/>
+        </p:nvPicPr>
+        <p:blipFill>
+          <a:blip r:embed="rId7"/>
+          <a:stretch>
+            <a:fillRect/>
+          </a:stretch>
+        </p:blipFill>
+        <p:spPr>
+          <a:xfrm>
+            <a:off x="5698084" y="5065776"/>
+            <a:ext cx="182880" cy="649224"/>
+          </a:xfrm>
+          <a:prstGeom prst="rect">
+            <a:avLst/>
+          </a:prstGeom>
+        </p:spPr>
+      </p:pic>
+      <p:sp>
+        <p:nvSpPr>
+          <p:cNvPr id="31" name="Shape 23"/>
+          <p:cNvSpPr/>
+          <p:nvPr/>
+        </p:nvSpPr>
+        <p:spPr>
+          <a:xfrm>
+            <a:off x="6255868" y="4956048"/>
+            <a:ext cx="3108960" cy="868680"/>
+          </a:xfrm>
+          <a:prstGeom prst="roundRect">
+            <a:avLst>
+              <a:gd name="adj" fmla="val 8421"/>
+            </a:avLst>
+          </a:prstGeom>
+          <a:solidFill>
+            <a:srgbClr val="FFFFFF">
+              <a:alpha val="10000"/>
+            </a:srgbClr>
+          </a:solidFill>
+          <a:ln w="9525">
+            <a:solidFill>
+              <a:srgbClr val="9DB8E8">
+                <a:alpha val="55000"/>
+              </a:srgbClr>
+            </a:solidFill>
+            <a:prstDash val="solid"/>
+          </a:ln>
+        </p:spPr>
+      </p:sp>
+      <p:sp>
+        <p:nvSpPr>
+          <p:cNvPr id="32" name="Shape 24"/>
+          <p:cNvSpPr/>
+          <p:nvPr/>
+        </p:nvSpPr>
+        <p:spPr>
+          <a:xfrm>
+            <a:off x="6420460" y="5152644"/>
+            <a:ext cx="475488" cy="475488"/>
+          </a:xfrm>
+          <a:prstGeom prst="ellipse">
+            <a:avLst/>
+          </a:prstGeom>
+          <a:solidFill>
+            <a:srgbClr val="E84910"/>
+          </a:solidFill>
+          <a:ln/>
+        </p:spPr>
+      </p:sp>
+      <p:pic>
+        <p:nvPicPr>
+          <p:cNvPr id="33" name="Image 6" descr="Local">    </p:cNvPr>
+          <p:cNvPicPr>
+            <a:picLocks noChangeAspect="1"/>
+          </p:cNvPicPr>
+          <p:nvPr/>
+        </p:nvPicPr>
+        <p:blipFill>
+          <a:blip r:embed="rId8"/>
+          <a:stretch>
+            <a:fillRect/>
+          </a:stretch>
+        </p:blipFill>
+        <p:spPr>
+          <a:xfrm>
+            <a:off x="6548476" y="5280660"/>
+            <a:ext cx="219456" cy="219456"/>
+          </a:xfrm>
+          <a:prstGeom prst="rect">
+            <a:avLst/>
+          </a:prstGeom>
+        </p:spPr>
+      </p:pic>
+      <p:sp>
+        <p:nvSpPr>
+          <p:cNvPr id="34" name="Text 25"/>
+          <p:cNvSpPr txBox="1"/>
+          <p:nvPr/>
+        </p:nvSpPr>
+        <p:spPr>
+          <a:xfrm>
+            <a:off x="7023964" y="5010912"/>
+            <a:ext cx="2231136" cy="758952"/>
+          </a:xfrm>
+          <a:prstGeom prst="rect">
+            <a:avLst/>
+          </a:prstGeom>
+          <a:noFill/>
+          <a:ln/>
+        </p:spPr>
+        <p:txBody>
+          <a:bodyPr wrap="square" lIns="0" tIns="0" rIns="0" bIns="0" rtlCol="0" anchor="ctr"/>
+          <a:lstStyle/>
+          <a:p>
+            <a:pPr algn="l" indent="0" marL="0">
+              <a:spcAft>
+                <a:spcPts val="100"/>
+              </a:spcAft>
+              <a:buNone/>
+            </a:pPr>
+            <a:r>
+              <a:rPr lang="en-US" sz="1400" b="1" dirty="0">
+                <a:solidFill>
+                  <a:srgbClr val="FFFFFF"/>
+                </a:solidFill>
+                <a:latin typeface="Arial" pitchFamily="34" charset="0"/>
+                <a:ea typeface="Arial" pitchFamily="34" charset="-122"/>
+                <a:cs typeface="Arial" pitchFamily="34" charset="-120"/>
+              </a:rPr>
+              <a:t>SENAI Paragominas</a:t>
+            </a:r>
+            <a:endParaRPr lang="en-US" sz="1400" dirty="0"/>
+          </a:p>
+          <a:p>
+            <a:pPr algn="l" indent="0" marL="0">
+              <a:spcAft>
+                <a:spcPts val="100"/>
+              </a:spcAft>
+              <a:buNone/>
+            </a:pPr>
+            <a:r>
+              <a:rPr lang="en-US" sz="1250" dirty="0">
+                <a:solidFill>
+                  <a:srgbClr val="D5E2FA"/>
+                </a:solidFill>
+                <a:latin typeface="Calibri" pitchFamily="34" charset="0"/>
+                <a:ea typeface="Calibri" pitchFamily="34" charset="-122"/>
+                <a:cs typeface="Calibri" pitchFamily="34" charset="-120"/>
+              </a:rPr>
+              <a:t>Rua Barão de Araruna, s/n</a:t>
+            </a:r>
+            <a:endParaRPr lang="en-US" sz="1400" dirty="0"/>
+          </a:p>
+          <a:p>
+            <a:pPr algn="l" indent="0" marL="0">
+              <a:spcAft>
+                <a:spcPts val="100"/>
+              </a:spcAft>
+              <a:buNone/>
+            </a:pPr>
+            <a:r>
+              <a:rPr lang="en-US" sz="1250" dirty="0">
+                <a:solidFill>
+                  <a:srgbClr val="D5E2FA"/>
+                </a:solidFill>
+                <a:latin typeface="Calibri" pitchFamily="34" charset="0"/>
+                <a:ea typeface="Calibri" pitchFamily="34" charset="-122"/>
+                <a:cs typeface="Calibri" pitchFamily="34" charset="-120"/>
+              </a:rPr>
+              <a:t>Promissão II – Paragominas/PA</a:t>
+            </a:r>
+            <a:endParaRPr lang="en-US" sz="1400" dirty="0"/>
+          </a:p>
+        </p:txBody>
+      </p:sp>
+      <p:sp>
+        <p:nvSpPr>
+          <p:cNvPr id="35" name="Text 26"/>
           <p:cNvSpPr txBox="1"/>
           <p:nvPr/>
         </p:nvSpPr>

</xml_diff>